<commit_message>
vault backup: 2026-10-27 12:02:21
</commit_message>
<xml_diff>
--- a/00_共同開発テンプレ/07_ライブラリ/外部資料/ハコノナカ_企画書.pptx
+++ b/00_共同開発テンプレ/07_ライブラリ/外部資料/ハコノナカ_企画書.pptx
@@ -243,7 +243,7 @@
           <a:p>
             <a:fld id="{5D7AAD1D-DEDA-4A6B-9C96-ABACE7990C54}" type="datetimeFigureOut">
               <a:rPr kumimoji="1" lang="ja-JP" altLang="en-US" smtClean="0"/>
-              <a:t>2026/10/24</a:t>
+              <a:t>2026/10/25</a:t>
             </a:fld>
             <a:endParaRPr kumimoji="1" lang="ja-JP" altLang="en-US"/>
           </a:p>
@@ -445,7 +445,7 @@
           <a:p>
             <a:fld id="{5D7AAD1D-DEDA-4A6B-9C96-ABACE7990C54}" type="datetimeFigureOut">
               <a:rPr kumimoji="1" lang="ja-JP" altLang="en-US" smtClean="0"/>
-              <a:t>2026/10/24</a:t>
+              <a:t>2026/10/26</a:t>
             </a:fld>
             <a:endParaRPr kumimoji="1" lang="ja-JP" altLang="en-US"/>
           </a:p>
@@ -657,7 +657,7 @@
           <a:p>
             <a:fld id="{5D7AAD1D-DEDA-4A6B-9C96-ABACE7990C54}" type="datetimeFigureOut">
               <a:rPr kumimoji="1" lang="ja-JP" altLang="en-US" smtClean="0"/>
-              <a:t>2026/10/24</a:t>
+              <a:t>2026/10/26</a:t>
             </a:fld>
             <a:endParaRPr kumimoji="1" lang="ja-JP" altLang="en-US"/>
           </a:p>
@@ -859,7 +859,7 @@
           <a:p>
             <a:fld id="{5D7AAD1D-DEDA-4A6B-9C96-ABACE7990C54}" type="datetimeFigureOut">
               <a:rPr kumimoji="1" lang="ja-JP" altLang="en-US" smtClean="0"/>
-              <a:t>2026/10/24</a:t>
+              <a:t>2026/10/26</a:t>
             </a:fld>
             <a:endParaRPr kumimoji="1" lang="ja-JP" altLang="en-US"/>
           </a:p>
@@ -1105,7 +1105,7 @@
           <a:p>
             <a:fld id="{5D7AAD1D-DEDA-4A6B-9C96-ABACE7990C54}" type="datetimeFigureOut">
               <a:rPr kumimoji="1" lang="ja-JP" altLang="en-US" smtClean="0"/>
-              <a:t>2026/10/24</a:t>
+              <a:t>2026/10/26</a:t>
             </a:fld>
             <a:endParaRPr kumimoji="1" lang="ja-JP" altLang="en-US"/>
           </a:p>
@@ -1401,7 +1401,7 @@
           <a:p>
             <a:fld id="{5D7AAD1D-DEDA-4A6B-9C96-ABACE7990C54}" type="datetimeFigureOut">
               <a:rPr kumimoji="1" lang="ja-JP" altLang="en-US" smtClean="0"/>
-              <a:t>2026/10/24</a:t>
+              <a:t>2026/10/26</a:t>
             </a:fld>
             <a:endParaRPr kumimoji="1" lang="ja-JP" altLang="en-US"/>
           </a:p>
@@ -1832,7 +1832,7 @@
           <a:p>
             <a:fld id="{5D7AAD1D-DEDA-4A6B-9C96-ABACE7990C54}" type="datetimeFigureOut">
               <a:rPr kumimoji="1" lang="ja-JP" altLang="en-US" smtClean="0"/>
-              <a:t>2026/10/24</a:t>
+              <a:t>2026/10/26</a:t>
             </a:fld>
             <a:endParaRPr kumimoji="1" lang="ja-JP" altLang="en-US"/>
           </a:p>
@@ -1950,7 +1950,7 @@
           <a:p>
             <a:fld id="{5D7AAD1D-DEDA-4A6B-9C96-ABACE7990C54}" type="datetimeFigureOut">
               <a:rPr kumimoji="1" lang="ja-JP" altLang="en-US" smtClean="0"/>
-              <a:t>2026/10/24</a:t>
+              <a:t>2026/10/26</a:t>
             </a:fld>
             <a:endParaRPr kumimoji="1" lang="ja-JP" altLang="en-US"/>
           </a:p>
@@ -2045,7 +2045,7 @@
           <a:p>
             <a:fld id="{5D7AAD1D-DEDA-4A6B-9C96-ABACE7990C54}" type="datetimeFigureOut">
               <a:rPr kumimoji="1" lang="ja-JP" altLang="en-US" smtClean="0"/>
-              <a:t>2026/10/24</a:t>
+              <a:t>2026/10/26</a:t>
             </a:fld>
             <a:endParaRPr kumimoji="1" lang="ja-JP" altLang="en-US"/>
           </a:p>
@@ -2354,7 +2354,7 @@
           <a:p>
             <a:fld id="{5D7AAD1D-DEDA-4A6B-9C96-ABACE7990C54}" type="datetimeFigureOut">
               <a:rPr kumimoji="1" lang="ja-JP" altLang="en-US" smtClean="0"/>
-              <a:t>2026/10/24</a:t>
+              <a:t>2026/10/26</a:t>
             </a:fld>
             <a:endParaRPr kumimoji="1" lang="ja-JP" altLang="en-US"/>
           </a:p>
@@ -2611,7 +2611,7 @@
           <a:p>
             <a:fld id="{5D7AAD1D-DEDA-4A6B-9C96-ABACE7990C54}" type="datetimeFigureOut">
               <a:rPr kumimoji="1" lang="ja-JP" altLang="en-US" smtClean="0"/>
-              <a:t>2026/10/24</a:t>
+              <a:t>2026/10/26</a:t>
             </a:fld>
             <a:endParaRPr kumimoji="1" lang="ja-JP" altLang="en-US"/>
           </a:p>
@@ -2861,7 +2861,7 @@
           <a:p>
             <a:fld id="{5D7AAD1D-DEDA-4A6B-9C96-ABACE7990C54}" type="datetimeFigureOut">
               <a:rPr kumimoji="1" lang="ja-JP" altLang="en-US" smtClean="0"/>
-              <a:t>2026/10/24</a:t>
+              <a:t>2026/10/25</a:t>
             </a:fld>
             <a:endParaRPr kumimoji="1" lang="ja-JP" altLang="en-US"/>
           </a:p>

</xml_diff>